<commit_message>
docs(experience): polish Hypervisor vocabulary for COMEX readers
Rewrite the Hypervisor pack so a COMEX or métier reader can follow
without an Agentium background: shared ten-word glossary, avis vs
appliquer, droits instead of IAM, and technical notes kept as footnotes.

Co-authored-by: thibaud.ishacian <thibaud.ishacian@gmail.com>
</commit_message>
<xml_diff>
--- a/docs/deck-agentium-decision-adoption.en.pptx
+++ b/docs/deck-agentium-decision-adoption.en.pptx
@@ -3824,7 +3824,7 @@
                 </a:solidFill>
                 <a:latin typeface="Consolas"/>
               </a:rPr>
-              <a:t>Portfolio                    System                      Application</a:t>
+              <a:t>Portfolio                    One System                  The application</a:t>
             </a:r>
           </a:p>
           <a:p>
@@ -3843,7 +3843,7 @@
                 </a:solidFill>
                 <a:latin typeface="Consolas"/>
               </a:rPr>
-              <a:t>/hypervisor                  Steer                       Studio</a:t>
+              <a:t>Hypervisor / Impact          Pilot (Steer)               Studio</a:t>
             </a:r>
           </a:p>
           <a:p>
@@ -3862,7 +3862,7 @@
                 </a:solidFill>
                 <a:latin typeface="Consolas"/>
               </a:rPr>
-              <a:t>accept / reject              Simulate → Approve          human gate</a:t>
+              <a:t>accept / reject              Simulate → Approve          human approval</a:t>
             </a:r>
           </a:p>
           <a:p>
@@ -3881,7 +3881,7 @@
                 </a:solidFill>
                 <a:latin typeface="Consolas"/>
               </a:rPr>
-              <a:t>signal                       → Act → Measure             approval</a:t>
+              <a:t>= an opinion                 → Apply → Measure           required</a:t>
             </a:r>
           </a:p>
           <a:p>
@@ -3900,7 +3900,7 @@
                 </a:solidFill>
                 <a:latin typeface="Consolas"/>
               </a:rPr>
-              <a:t>                             bounded enactment           required</a:t>
+              <a:t>                             bounded change</a:t>
             </a:r>
           </a:p>
         </p:txBody>
@@ -3937,25 +3937,7 @@
                 </a:solidFill>
                 <a:latin typeface="Calibri"/>
               </a:rPr>
-              <a:t>First actuator: a </a:t>
-            </a:r>
-            <a:r>
-              <a:rPr sz="1600" b="0" i="1">
-                <a:solidFill>
-                  <a:srgbClr val="151A23"/>
-                </a:solidFill>
-                <a:latin typeface="Calibri"/>
-              </a:rPr>
-              <a:t>guardrails</a:t>
-            </a:r>
-            <a:r>
-              <a:rPr sz="1600" b="0" i="0">
-                <a:solidFill>
-                  <a:srgbClr val="151A23"/>
-                </a:solidFill>
-                <a:latin typeface="Calibri"/>
-              </a:rPr>
-              <a:t> patch, if the System declares it and the Membrane allows it. Otherwise: </a:t>
+              <a:t>First allowed change: a guardrail adjustment, if the System declares it and execution control allows it. Otherwise: </a:t>
             </a:r>
             <a:r>
               <a:rPr sz="1600" b="1" i="0">
@@ -4352,7 +4334,7 @@
                 </a:solidFill>
                 <a:latin typeface="Calibri"/>
               </a:rPr>
-              <a:t>•  The Hypervisor does not apply a policy by itself.</a:t>
+              <a:t>•  The Hypervisor does not apply a rule by itself.</a:t>
             </a:r>
           </a:p>
         </p:txBody>
@@ -4384,7 +4366,7 @@
                 </a:solidFill>
                 <a:latin typeface="Calibri"/>
               </a:rPr>
-              <a:t>•  Portfolio what-if / live levers are </a:t>
+              <a:t>•  Portfolio “what if” / live levers are </a:t>
             </a:r>
             <a:r>
               <a:rPr sz="1600" b="1" i="0">
@@ -4434,25 +4416,7 @@
                 </a:solidFill>
                 <a:latin typeface="Calibri"/>
               </a:rPr>
-              <a:t>•  Mission Room (</a:t>
-            </a:r>
-            <a:r>
-              <a:rPr sz="1600" b="0" i="0">
-                <a:solidFill>
-                  <a:srgbClr val="0E6B6A"/>
-                </a:solidFill>
-                <a:latin typeface="Consolas"/>
-              </a:rPr>
-              <a:t>/hypervisor/mission-room</a:t>
-            </a:r>
-            <a:r>
-              <a:rPr sz="1600" b="0" i="0">
-                <a:solidFill>
-                  <a:srgbClr val="151A23"/>
-                </a:solidFill>
-                <a:latin typeface="Calibri"/>
-              </a:rPr>
-              <a:t>) is a </a:t>
+              <a:t>•  Mission Room is a </a:t>
             </a:r>
             <a:r>
               <a:rPr sz="1600" b="1" i="0">
@@ -4461,7 +4425,7 @@
                 </a:solidFill>
                 <a:latin typeface="Calibri"/>
               </a:rPr>
-              <a:t>workspace app</a:t>
+              <a:t>workspace application</a:t>
             </a:r>
             <a:r>
               <a:rPr sz="1600" b="0" i="0">
@@ -4534,7 +4498,7 @@
                 </a:solidFill>
                 <a:latin typeface="Calibri"/>
               </a:rPr>
-              <a:t>•  “Hours or euros saved” without a Lot 8 baseline = acceptance hole (O5).</a:t>
+              <a:t>•  “Hours or euros saved” without a measurement after a change = a gap, not a KPI.</a:t>
             </a:r>
           </a:p>
         </p:txBody>
@@ -4928,7 +4892,7 @@
                 </a:solidFill>
                 <a:latin typeface="Consolas"/>
               </a:rPr>
-              <a:t>1. Finish a task                Work / Studio</a:t>
+              <a:t>1. Finish a task                      Work / Studio</a:t>
             </a:r>
           </a:p>
           <a:p>
@@ -4947,7 +4911,7 @@
                 </a:solidFill>
                 <a:latin typeface="Consolas"/>
               </a:rPr>
-              <a:t>2. Bind the result to a Run     Citation · /runs · companion</a:t>
+              <a:t>2. Bind the result to an execution    Opened source · companion</a:t>
             </a:r>
           </a:p>
           <a:p>
@@ -4966,7 +4930,7 @@
                 </a:solidFill>
                 <a:latin typeface="Consolas"/>
               </a:rPr>
-              <a:t>3. Bind the Run to a decision   Impact · gates · Steer</a:t>
+              <a:t>3. Bind the execution to a decision   Impact · approval · Steer</a:t>
             </a:r>
           </a:p>
         </p:txBody>
@@ -5092,7 +5056,7 @@
                           </a:solidFill>
                           <a:latin typeface="Calibri"/>
                         </a:rPr>
-                        <a:t>IAM</a:t>
+                        <a:t>Access rights</a:t>
                       </a:r>
                     </a:p>
                   </a:txBody>
@@ -5163,7 +5127,7 @@
                           </a:solidFill>
                           <a:latin typeface="Calibri"/>
                         </a:rPr>
-                        <a:t>Screen density (builder / operator / executive)</a:t>
+                        <a:t>Screen density (build / operate / direct)</a:t>
                       </a:r>
                     </a:p>
                   </a:txBody>
@@ -5740,7 +5704,7 @@
                 </a:solidFill>
                 <a:latin typeface="Calibri"/>
               </a:rPr>
-              <a:t>`/help/value`</a:t>
+              <a:t>Value help</a:t>
             </a:r>
             <a:r>
               <a:rPr sz="1600" b="0" i="0">
@@ -6177,13 +6141,13 @@
               <a:t>1.  </a:t>
             </a:r>
             <a:r>
-              <a:rPr sz="1600" b="0" i="0">
-                <a:solidFill>
-                  <a:srgbClr val="0E6B6A"/>
-                </a:solidFill>
-                <a:latin typeface="Consolas"/>
-              </a:rPr>
-              <a:t>/work</a:t>
+              <a:rPr sz="1600" b="1" i="0">
+                <a:solidFill>
+                  <a:srgbClr val="151A23"/>
+                </a:solidFill>
+                <a:latin typeface="Calibri"/>
+              </a:rPr>
+              <a:t>Work</a:t>
             </a:r>
             <a:r>
               <a:rPr sz="1600" b="0" i="0">
@@ -6233,7 +6197,7 @@
                 </a:solidFill>
                 <a:latin typeface="Calibri"/>
               </a:rPr>
-              <a:t>Open the citation.</a:t>
+              <a:t>Open the source.</a:t>
             </a:r>
           </a:p>
         </p:txBody>
@@ -6265,25 +6229,7 @@
                 </a:solidFill>
                 <a:latin typeface="Calibri"/>
               </a:rPr>
-              <a:t>3.  (Optional) NorthForge: </a:t>
-            </a:r>
-            <a:r>
-              <a:rPr sz="1600" b="0" i="0">
-                <a:solidFill>
-                  <a:srgbClr val="0E6B6A"/>
-                </a:solidFill>
-                <a:latin typeface="Consolas"/>
-              </a:rPr>
-              <a:t>/work/getting-started</a:t>
-            </a:r>
-            <a:r>
-              <a:rPr sz="1600" b="0" i="0">
-                <a:solidFill>
-                  <a:srgbClr val="151A23"/>
-                </a:solidFill>
-                <a:latin typeface="Calibri"/>
-              </a:rPr>
-              <a:t> — four steps, fictional example.</a:t>
+              <a:t>3.  (Optional) Guided example — four steps, fictional case.</a:t>
             </a:r>
           </a:p>
         </p:txBody>
@@ -6315,7 +6261,7 @@
                 </a:solidFill>
                 <a:latin typeface="Calibri"/>
               </a:rPr>
-              <a:t>4.  If a gate appears: </a:t>
+              <a:t>4.  If an approval appears: </a:t>
             </a:r>
             <a:r>
               <a:rPr sz="1600" b="1" i="0">
@@ -6785,7 +6731,7 @@
                 </a:solidFill>
                 <a:latin typeface="Calibri"/>
               </a:rPr>
-              <a:t> gate or the review queue — read before signing.</a:t>
+              <a:t> approval or the review queue — read before signing.</a:t>
             </a:r>
           </a:p>
         </p:txBody>
@@ -6835,7 +6781,7 @@
                 </a:solidFill>
                 <a:latin typeface="Calibri"/>
               </a:rPr>
-              <a:t> feed — signal, not enactment.</a:t>
+              <a:t> queue — an opinion, not an application.</a:t>
             </a:r>
           </a:p>
         </p:txBody>
@@ -6867,7 +6813,7 @@
                 </a:solidFill>
                 <a:latin typeface="Calibri"/>
               </a:rPr>
-              <a:t>3.  If — and only if — the value loop is active on </a:t>
+              <a:t>3.  If — and only if — the value loop is open on </a:t>
             </a:r>
             <a:r>
               <a:rPr sz="1600" b="1" i="0">
@@ -6922,7 +6868,7 @@
                 </a:solidFill>
                 <a:latin typeface="Calibri"/>
               </a:rPr>
-              <a:t>Simulate → Approve → Act → Measure</a:t>
+              <a:t>Simulate → Approve → Apply → Measure</a:t>
             </a:r>
             <a:r>
               <a:rPr sz="1600" b="0" i="0">
@@ -6968,7 +6914,7 @@
                 </a:solidFill>
                 <a:latin typeface="Calibri"/>
               </a:rPr>
-              <a:t>The model cannot accept a gate. A stale decision is refused.</a:t>
+              <a:t>The model cannot accept in your place. A decision that is too old is refused.</a:t>
             </a:r>
           </a:p>
         </p:txBody>
@@ -7436,7 +7382,7 @@
                           </a:solidFill>
                           <a:latin typeface="Calibri"/>
                         </a:rPr>
-                        <a:t>Shipped, flag adoption_experience_v1 off</a:t>
+                        <a:t>Shipped, welcome path off by default</a:t>
                       </a:r>
                     </a:p>
                   </a:txBody>
@@ -8288,7 +8234,7 @@
                           </a:solidFill>
                           <a:latin typeface="Calibri"/>
                         </a:rPr>
-                        <a:t>Mehdi steward</a:t>
+                        <a:t>Mehdi pilot</a:t>
                       </a:r>
                     </a:p>
                   </a:txBody>
@@ -9060,7 +9006,7 @@
                 </a:solidFill>
                 <a:latin typeface="Calibri"/>
               </a:rPr>
-              <a:t> — only if the value flag is really on. Otherwise say so.</a:t>
+              <a:t> — only if the value loop is really open. Otherwise say so.</a:t>
             </a:r>
           </a:p>
         </p:txBody>
@@ -9101,7 +9047,7 @@
                 </a:solidFill>
                 <a:latin typeface="Calibri"/>
               </a:rPr>
-              <a:t>`/help/value`</a:t>
+              <a:t>Value help</a:t>
             </a:r>
             <a:r>
               <a:rPr sz="1600" b="0" i="0">
@@ -12635,7 +12581,7 @@
                           </a:solidFill>
                           <a:latin typeface="Calibri"/>
                         </a:rPr>
-                        <a:t>/hypervisor</a:t>
+                        <a:t>Hypervisor / Impact</a:t>
                       </a:r>
                     </a:p>
                   </a:txBody>
@@ -12706,7 +12652,7 @@
                           </a:solidFill>
                           <a:latin typeface="Calibri"/>
                         </a:rPr>
-                        <a:t>/work · Studio</a:t>
+                        <a:t>Work · Studio</a:t>
                       </a:r>
                     </a:p>
                   </a:txBody>
@@ -12777,7 +12723,7 @@
                           </a:solidFill>
                           <a:latin typeface="Calibri"/>
                         </a:rPr>
-                        <a:t>/runs · review queue · Diagnostics</a:t>
+                        <a:t>Executions · review queue · Diagnostics</a:t>
                       </a:r>
                     </a:p>
                   </a:txBody>
@@ -12848,7 +12794,7 @@
                           </a:solidFill>
                           <a:latin typeface="Calibri"/>
                         </a:rPr>
-                        <a:t>Impact feed · Work gates · Steer</a:t>
+                        <a:t>Impact queue · approval in the app · Steer</a:t>
                       </a:r>
                     </a:p>
                   </a:txBody>
@@ -13218,7 +13164,7 @@
                 </a:solidFill>
                 <a:latin typeface="Calibri"/>
               </a:rPr>
-              <a:t> — a System serves a Capability, not an orphan prompt.</a:t>
+              <a:t> — a System serves a business capability, not an orphan prompt.</a:t>
             </a:r>
           </a:p>
         </p:txBody>
@@ -13268,7 +13214,7 @@
                 </a:solidFill>
                 <a:latin typeface="Calibri"/>
               </a:rPr>
-              <a:t> — the business consumes a </a:t>
+              <a:t> — the business uses a </a:t>
             </a:r>
             <a:r>
               <a:rPr sz="1600" b="1" i="0">
@@ -13286,7 +13232,7 @@
                 </a:solidFill>
                 <a:latin typeface="Calibri"/>
               </a:rPr>
-              <a:t> Experience.</a:t>
+              <a:t> application.</a:t>
             </a:r>
           </a:p>
         </p:txBody>
@@ -13336,7 +13282,7 @@
                 </a:solidFill>
                 <a:latin typeface="Calibri"/>
               </a:rPr>
-              <a:t> — every answer has a Run (cost, context, lineage).</a:t>
+              <a:t> — every answer has an execution (cost, context, lineage).</a:t>
             </a:r>
           </a:p>
         </p:txBody>
@@ -13386,7 +13332,7 @@
                 </a:solidFill>
                 <a:latin typeface="Calibri"/>
               </a:rPr>
-              <a:t> — policies, IAM, audit. Never “prompt only”.</a:t>
+              <a:t> — rules, access rights, log. Never “prompt only”.</a:t>
             </a:r>
           </a:p>
         </p:txBody>
@@ -14050,43 +13996,25 @@
                 </a:solidFill>
                 <a:latin typeface="Calibri"/>
               </a:rPr>
-              <a:t>Route: </a:t>
+              <a:t>The menu may say </a:t>
+            </a:r>
+            <a:r>
+              <a:rPr sz="1600" b="1" i="0">
+                <a:solidFill>
+                  <a:srgbClr val="151A23"/>
+                </a:solidFill>
+                <a:latin typeface="Calibri"/>
+              </a:rPr>
+              <a:t>Impact</a:t>
             </a:r>
             <a:r>
               <a:rPr sz="1600" b="0" i="0">
                 <a:solidFill>
-                  <a:srgbClr val="0E6B6A"/>
-                </a:solidFill>
-                <a:latin typeface="Consolas"/>
-              </a:rPr>
-              <a:t>/hypervisor</a:t>
-            </a:r>
-            <a:r>
-              <a:rPr sz="1600" b="0" i="0">
-                <a:solidFill>
-                  <a:srgbClr val="151A23"/>
-                </a:solidFill>
-                <a:latin typeface="Calibri"/>
-              </a:rPr>
-              <a:t> Adoption rail: </a:t>
-            </a:r>
-            <a:r>
-              <a:rPr sz="1600" b="1" i="0">
-                <a:solidFill>
-                  <a:srgbClr val="151A23"/>
-                </a:solidFill>
-                <a:latin typeface="Calibri"/>
-              </a:rPr>
-              <a:t>Impact</a:t>
-            </a:r>
-            <a:r>
-              <a:rPr sz="1600" b="0" i="0">
-                <a:solidFill>
-                  <a:srgbClr val="151A23"/>
-                </a:solidFill>
-                <a:latin typeface="Calibri"/>
-              </a:rPr>
-              <a:t> — the name does not establish the outcome.</a:t>
+                  <a:srgbClr val="151A23"/>
+                </a:solidFill>
+                <a:latin typeface="Calibri"/>
+              </a:rPr>
+              <a:t> — the name does not establish an economic result.</a:t>
             </a:r>
           </a:p>
         </p:txBody>
@@ -14272,7 +14200,7 @@
                 </a:solidFill>
                 <a:latin typeface="Calibri"/>
               </a:rPr>
-              <a:t>Two readings, one Decision object</a:t>
+              <a:t>Two readings, one opinion to sign</a:t>
             </a:r>
           </a:p>
         </p:txBody>
@@ -14442,7 +14370,7 @@
                 </a:solidFill>
                 <a:latin typeface="Calibri"/>
               </a:rPr>
-              <a:t>Accept / Reject = signal</a:t>
+              <a:t>Accept / Reject = an opinion</a:t>
             </a:r>
             <a:r>
               <a:rPr sz="1600" b="0" i="0">
@@ -14460,7 +14388,7 @@
                 </a:solidFill>
                 <a:latin typeface="Calibri"/>
               </a:rPr>
-              <a:t>Apply a policy</a:t>
+              <a:t>Apply a rule change</a:t>
             </a:r>
             <a:r>
               <a:rPr sz="1600" b="0" i="0">
@@ -14553,7 +14481,7 @@
                 </a:solidFill>
                 <a:latin typeface="Calibri"/>
               </a:rPr>
-              <a:t>“Validating here records a decision. Changing a System goes through Steer.”</a:t>
+              <a:t>“Validating here records an opinion. Changing a System goes through its pilot screen.”</a:t>
             </a:r>
           </a:p>
         </p:txBody>
@@ -14594,7 +14522,7 @@
                           </a:solidFill>
                           <a:latin typeface="Calibri"/>
                         </a:rPr>
-                        <a:t>v1 Value balance sheet</a:t>
+                        <a:t>Older view — Value balance sheet</a:t>
                       </a:r>
                     </a:p>
                   </a:txBody>
@@ -14617,7 +14545,7 @@
                           </a:solidFill>
                           <a:latin typeface="Calibri"/>
                         </a:rPr>
-                        <a:t>v2 Ledger (hypervisor_v2)</a:t>
+                        <a:t>Newer view — Ledger</a:t>
                       </a:r>
                     </a:p>
                   </a:txBody>
@@ -14642,7 +14570,7 @@
                           </a:solidFill>
                           <a:latin typeface="Calibri"/>
                         </a:rPr>
-                        <a:t>Estimated net value, ROI, SCAN</a:t>
+                        <a:t>Estimated net value, ROI, signals</a:t>
                       </a:r>
                     </a:p>
                   </a:txBody>
@@ -14690,7 +14618,7 @@
                           </a:solidFill>
                           <a:latin typeface="Calibri"/>
                         </a:rPr>
-                        <a:t>+ value-loop aggregate</a:t>
+                        <a:t>+ value-loop summary</a:t>
                       </a:r>
                     </a:p>
                   </a:txBody>

</xml_diff>